<commit_message>
fix(pptx): update presentasi sesuai skripsi terkini
- Slide 10: Gambar 4.9 → 4.8 (reindex)
- Slide 13: Hapus klaim 240→12 menit/95%, pakai < 200ms
- Slide 13: Chart data update (240 vs 0.2 detik)
- Slide 14: Kesimpulan update (< 200ms per request)
</commit_message>
<xml_diff>
--- a/Skripsi_Firman_Firdaus.pptx
+++ b/Skripsi_Firman_Firdaus.pptx
@@ -471,7 +471,7 @@
               <c:strCache>
                 <c:ptCount val="1"/>
                 <c:pt idx="0">
-                  <c:v>Waktu Proses (menit)</c:v>
+                  <c:v>Waktu Proses (detik)</c:v>
                 </c:pt>
               </c:strCache>
             </c:strRef>
@@ -561,7 +561,7 @@
                   <c:v>Sebelum (Manual)</c:v>
                 </c:pt>
                 <c:pt idx="1">
-                  <c:v>Sesudah (Sistem)</c:v>
+                  <c:v>Sesudah (Go Backend)</c:v>
                 </c:pt>
               </c:strCache>
             </c:strRef>
@@ -576,7 +576,7 @@
                   <c:v>240</c:v>
                 </c:pt>
                 <c:pt idx="1">
-                  <c:v>12</c:v>
+                  <c:v>0.2</c:v>
                 </c:pt>
               </c:numCache>
             </c:numRef>
@@ -3003,7 +3003,7 @@
                 <a:ea typeface="Calibri" pitchFamily="34" charset="-122"/>
                 <a:cs typeface="Calibri" pitchFamily="34" charset="-120"/>
               </a:rPr>
-              <a:t>Gambar 4.9 — Diagram Arsitektur Sistem (dokumen skripsi)</a:t>
+              <a:t>Gambar 4.8 — Diagram Arsitektur Sistem (dokumen skripsi)</a:t>
             </a:r>
             <a:endParaRPr lang="en-US" sz="950" dirty="0"/>
           </a:p>
@@ -3030,6 +3030,10 @@
           </a:solidFill>
           <a:ln/>
         </p:spPr>
+        <p:txBody>
+          <a:bodyPr/>
+          <a:p/>
+        </p:txBody>
       </p:sp>
       <p:sp>
         <p:nvSpPr>
@@ -3130,6 +3134,10 @@
           </a:solidFill>
           <a:ln/>
         </p:spPr>
+        <p:txBody>
+          <a:bodyPr/>
+          <a:p/>
+        </p:txBody>
       </p:sp>
       <p:sp>
         <p:nvSpPr>
@@ -3230,6 +3238,10 @@
           </a:solidFill>
           <a:ln/>
         </p:spPr>
+        <p:txBody>
+          <a:bodyPr/>
+          <a:p/>
+        </p:txBody>
       </p:sp>
       <p:sp>
         <p:nvSpPr>
@@ -3330,6 +3342,10 @@
           </a:solidFill>
           <a:ln/>
         </p:spPr>
+        <p:txBody>
+          <a:bodyPr/>
+          <a:p/>
+        </p:txBody>
       </p:sp>
       <p:sp>
         <p:nvSpPr>
@@ -3430,6 +3446,10 @@
           </a:solidFill>
           <a:ln/>
         </p:spPr>
+        <p:txBody>
+          <a:bodyPr/>
+          <a:p/>
+        </p:txBody>
       </p:sp>
       <p:sp>
         <p:nvSpPr>
@@ -4853,6 +4873,10 @@
           </a:solidFill>
           <a:ln/>
         </p:spPr>
+        <p:txBody>
+          <a:bodyPr/>
+          <a:p/>
+        </p:txBody>
       </p:sp>
       <p:sp>
         <p:nvSpPr>
@@ -4887,7 +4911,7 @@
                 <a:ea typeface="Cambria" pitchFamily="34" charset="-122"/>
                 <a:cs typeface="Cambria" pitchFamily="34" charset="-120"/>
               </a:rPr>
-              <a:t>95%</a:t>
+              <a:t>&lt; 200ms</a:t>
             </a:r>
             <a:endParaRPr lang="en-US" sz="4600" dirty="0"/>
           </a:p>
@@ -4929,7 +4953,7 @@
                 <a:ea typeface="Calibri" pitchFamily="34" charset="-122"/>
                 <a:cs typeface="Calibri" pitchFamily="34" charset="-120"/>
               </a:rPr>
-              <a:t>Peningkatan efisiensi waktu pemrosesan laporan bulanan (dari 240 menit menjadi 12 menit)</a:t>
+              <a:t>Peningkatan efisiensi waktu pemrosesan laporan bulanan (dari proses manual menjadi real-time)</a:t>
             </a:r>
             <a:endParaRPr lang="en-US" sz="1150" dirty="0"/>
           </a:p>
@@ -5241,6 +5265,10 @@
           </a:solidFill>
           <a:ln/>
         </p:spPr>
+        <p:txBody>
+          <a:bodyPr/>
+          <a:p/>
+        </p:txBody>
       </p:sp>
       <p:sp>
         <p:nvSpPr>
@@ -5345,7 +5373,7 @@
                 <a:ea typeface="Calibri" pitchFamily="34" charset="-122"/>
                 <a:cs typeface="Calibri" pitchFamily="34" charset="-120"/>
               </a:rPr>
-              <a:t>Efisiensi pemrosesan laporan bulanan meningkat 95% (240 → 12 menit) dan eliminasi kesalahan kalkulasi manual.</a:t>
+              <a:t>Efisiensi pemrosesan laporan bulanan meningkat real-time (&lt; 200ms per request) dan eliminasi kesalahan kalkulasi manual.</a:t>
             </a:r>
             <a:endParaRPr lang="en-US" sz="1250" dirty="0"/>
           </a:p>
@@ -5396,6 +5424,10 @@
           </a:solidFill>
           <a:ln/>
         </p:spPr>
+        <p:txBody>
+          <a:bodyPr/>
+          <a:p/>
+        </p:txBody>
       </p:sp>
       <p:sp>
         <p:nvSpPr>

</xml_diff>